<commit_message>
docs : add slide gherkin
</commit_message>
<xml_diff>
--- a/presentation/couverture-code-conference-dynamite.pptx
+++ b/presentation/couverture-code-conference-dynamite.pptx
@@ -17,23 +17,23 @@
     <p:sldId id="264" r:id="rId11"/>
     <p:sldId id="266" r:id="rId12"/>
     <p:sldId id="267" r:id="rId13"/>
-    <p:sldId id="285" r:id="rId34"/>
-    <p:sldId id="268" r:id="rId14"/>
-    <p:sldId id="269" r:id="rId15"/>
-    <p:sldId id="270" r:id="rId16"/>
-    <p:sldId id="271" r:id="rId17"/>
-    <p:sldId id="272" r:id="rId18"/>
-    <p:sldId id="273" r:id="rId19"/>
-    <p:sldId id="274" r:id="rId20"/>
-    <p:sldId id="275" r:id="rId21"/>
-    <p:sldId id="276" r:id="rId22"/>
-    <p:sldId id="277" r:id="rId23"/>
-    <p:sldId id="278" r:id="rId24"/>
-    <p:sldId id="279" r:id="rId25"/>
-    <p:sldId id="280" r:id="rId26"/>
-    <p:sldId id="282" r:id="rId27"/>
-    <p:sldId id="283" r:id="rId28"/>
-    <p:sldId id="284" r:id="rId29"/>
+    <p:sldId id="285" r:id="rId14"/>
+    <p:sldId id="268" r:id="rId15"/>
+    <p:sldId id="269" r:id="rId16"/>
+    <p:sldId id="270" r:id="rId17"/>
+    <p:sldId id="271" r:id="rId18"/>
+    <p:sldId id="272" r:id="rId19"/>
+    <p:sldId id="273" r:id="rId20"/>
+    <p:sldId id="274" r:id="rId21"/>
+    <p:sldId id="275" r:id="rId22"/>
+    <p:sldId id="276" r:id="rId23"/>
+    <p:sldId id="277" r:id="rId24"/>
+    <p:sldId id="278" r:id="rId25"/>
+    <p:sldId id="279" r:id="rId26"/>
+    <p:sldId id="280" r:id="rId27"/>
+    <p:sldId id="282" r:id="rId28"/>
+    <p:sldId id="283" r:id="rId29"/>
+    <p:sldId id="284" r:id="rId30"/>
   </p:sldIdLst>
   <p:sldSz cx="12192000" cy="6858000"/>
   <p:notesSz cx="6858000" cy="9144000"/>
@@ -7862,7 +7862,7 @@
 </file>
 
 <file path=ppt/slides/slide13.xml><?xml version="1.0" encoding="utf-8"?>
-<p:sld xmlns:a="http://schemas.openxmlformats.org/drawingml/2006/main" xmlns:p="http://schemas.openxmlformats.org/presentationml/2006/main" xmlns:r="http://schemas.openxmlformats.org/officeDocument/2006/relationships">
+<p:sld xmlns:a="http://schemas.openxmlformats.org/drawingml/2006/main" xmlns:r="http://schemas.openxmlformats.org/officeDocument/2006/relationships" xmlns:p="http://schemas.openxmlformats.org/presentationml/2006/main">
   <p:cSld>
     <p:bg>
       <p:bgPr>
@@ -7878,7 +7878,14 @@
         <p:cNvGrpSpPr/>
         <p:nvPr/>
       </p:nvGrpSpPr>
-      <p:grpSpPr/>
+      <p:grpSpPr>
+        <a:xfrm>
+          <a:off x="0" y="0"/>
+          <a:ext cx="0" cy="0"/>
+          <a:chOff x="0" y="0"/>
+          <a:chExt cx="0" cy="0"/>
+        </a:xfrm>
+      </p:grpSpPr>
       <p:sp>
         <p:nvSpPr>
           <p:cNvPr id="2" name="Rectangle 1"/>
@@ -7920,6 +7927,7 @@
           <a:lstStyle/>
           <a:p>
             <a:pPr algn="ctr"/>
+            <a:endParaRPr/>
           </a:p>
         </p:txBody>
       </p:sp>
@@ -7960,7 +7968,7 @@
           </a:fontRef>
         </p:style>
         <p:txBody>
-          <a:bodyPr rtlCol="0" anchor="ctr" lIns="256032" rIns="45720" tIns="18288" bIns="18288"/>
+          <a:bodyPr lIns="256032" tIns="18288" rIns="45720" bIns="18288" rtlCol="0" anchor="ctr"/>
           <a:lstStyle/>
           <a:p>
             <a:pPr algn="l"/>
@@ -7993,7 +8001,7 @@
           <a:noFill/>
         </p:spPr>
         <p:txBody>
-          <a:bodyPr wrap="square" lIns="0" rIns="0" tIns="0" bIns="0">
+          <a:bodyPr wrap="square" lIns="0" tIns="0" rIns="0" bIns="0">
             <a:spAutoFit/>
           </a:bodyPr>
           <a:lstStyle/>
@@ -8023,8 +8031,8 @@
         </p:nvSpPr>
         <p:spPr>
           <a:xfrm>
-            <a:off x="822960" y="1965960"/>
-            <a:ext cx="10515600" cy="3840480"/>
+            <a:off x="655695" y="1638116"/>
+            <a:ext cx="10195560" cy="4206240"/>
           </a:xfrm>
           <a:prstGeom prst="roundRect">
             <a:avLst/>
@@ -8056,6 +8064,7 @@
           <a:lstStyle/>
           <a:p>
             <a:pPr algn="ctr"/>
+            <a:endParaRPr/>
           </a:p>
         </p:txBody>
       </p:sp>
@@ -8067,7 +8076,7 @@
         </p:nvSpPr>
         <p:spPr>
           <a:xfrm>
-            <a:off x="1024128" y="2093976"/>
+            <a:off x="1280605" y="1766132"/>
             <a:ext cx="109728" cy="109728"/>
           </a:xfrm>
           <a:prstGeom prst="ellipse">
@@ -8100,6 +8109,7 @@
           <a:lstStyle/>
           <a:p>
             <a:pPr algn="ctr"/>
+            <a:endParaRPr/>
           </a:p>
         </p:txBody>
       </p:sp>
@@ -8111,7 +8121,7 @@
         </p:nvSpPr>
         <p:spPr>
           <a:xfrm>
-            <a:off x="1243584" y="2093976"/>
+            <a:off x="1500061" y="1766132"/>
             <a:ext cx="109728" cy="109728"/>
           </a:xfrm>
           <a:prstGeom prst="ellipse">
@@ -8144,6 +8154,7 @@
           <a:lstStyle/>
           <a:p>
             <a:pPr algn="ctr"/>
+            <a:endParaRPr/>
           </a:p>
         </p:txBody>
       </p:sp>
@@ -8155,7 +8166,7 @@
         </p:nvSpPr>
         <p:spPr>
           <a:xfrm>
-            <a:off x="1463040" y="2093976"/>
+            <a:off x="1719517" y="1766132"/>
             <a:ext cx="109728" cy="109728"/>
           </a:xfrm>
           <a:prstGeom prst="ellipse">
@@ -8188,6 +8199,7 @@
           <a:lstStyle/>
           <a:p>
             <a:pPr algn="ctr"/>
+            <a:endParaRPr/>
           </a:p>
         </p:txBody>
       </p:sp>
@@ -8199,8 +8211,8 @@
         </p:nvSpPr>
         <p:spPr>
           <a:xfrm>
-            <a:off x="1143000" y="2441448"/>
-            <a:ext cx="9875520" cy="3291840"/>
+            <a:off x="1343720" y="2358928"/>
+            <a:ext cx="8647771" cy="2907206"/>
           </a:xfrm>
           <a:prstGeom prst="rect">
             <a:avLst/>
@@ -8208,82 +8220,208 @@
           <a:noFill/>
         </p:spPr>
         <p:txBody>
-          <a:bodyPr wrap="square" lIns="0" rIns="0" tIns="0" bIns="0">
+          <a:bodyPr wrap="square" lIns="0" tIns="0" rIns="0" bIns="0">
             <a:spAutoFit/>
           </a:bodyPr>
           <a:lstStyle/>
           <a:p>
             <a:pPr algn="l">
               <a:lnSpc>
-                <a:spcPct val="120000"/>
+                <a:spcPct val="110000"/>
               </a:lnSpc>
             </a:pPr>
             <a:r>
-              <a:rPr sz="1350" b="0" i="0">
+              <a:rPr sz="1150" b="0" i="0" dirty="0">
                 <a:solidFill>
                   <a:srgbClr val="E7ECF5"/>
                 </a:solidFill>
                 <a:latin typeface="Menlo"/>
               </a:rPr>
-              <a:t>public class EventStepDefinitions {</a:t>
+              <a:t>public class </a:t>
+            </a:r>
+            <a:r>
+              <a:rPr sz="1150" b="0" i="0" dirty="0" err="1">
+                <a:solidFill>
+                  <a:srgbClr val="E7ECF5"/>
+                </a:solidFill>
+                <a:latin typeface="Menlo"/>
+              </a:rPr>
+              <a:t>EventStepDefinitions</a:t>
+            </a:r>
+            <a:r>
+              <a:rPr sz="1150" b="0" i="0" dirty="0">
+                <a:solidFill>
+                  <a:srgbClr val="E7ECF5"/>
+                </a:solidFill>
+                <a:latin typeface="Menlo"/>
+              </a:rPr>
+              <a:t> {</a:t>
             </a:r>
           </a:p>
           <a:p>
             <a:pPr algn="l">
               <a:lnSpc>
-                <a:spcPct val="120000"/>
+                <a:spcPct val="110000"/>
               </a:lnSpc>
             </a:pPr>
             <a:r>
-              <a:rPr sz="1350" b="0" i="0">
+              <a:rPr sz="1150" b="0" i="0" dirty="0">
                 <a:solidFill>
                   <a:srgbClr val="E7ECF5"/>
                 </a:solidFill>
                 <a:latin typeface="Menlo"/>
               </a:rPr>
-              <a:t>    @Given("j'ai déjà l'événement {string} de {string} à {string} le {string}")</a:t>
+              <a:t>    @Given("</a:t>
+            </a:r>
+            <a:r>
+              <a:rPr sz="1150" b="0" i="0" dirty="0" err="1">
+                <a:solidFill>
+                  <a:srgbClr val="E7ECF5"/>
+                </a:solidFill>
+                <a:latin typeface="Menlo"/>
+              </a:rPr>
+              <a:t>j'ai</a:t>
+            </a:r>
+            <a:r>
+              <a:rPr sz="1150" b="0" i="0" dirty="0">
+                <a:solidFill>
+                  <a:srgbClr val="E7ECF5"/>
+                </a:solidFill>
+                <a:latin typeface="Menlo"/>
+              </a:rPr>
+              <a:t> déjà </a:t>
+            </a:r>
+            <a:r>
+              <a:rPr sz="1150" b="0" i="0" dirty="0" err="1">
+                <a:solidFill>
+                  <a:srgbClr val="E7ECF5"/>
+                </a:solidFill>
+                <a:latin typeface="Menlo"/>
+              </a:rPr>
+              <a:t>l'événement</a:t>
+            </a:r>
+            <a:r>
+              <a:rPr sz="1150" b="0" i="0" dirty="0">
+                <a:solidFill>
+                  <a:srgbClr val="E7ECF5"/>
+                </a:solidFill>
+                <a:latin typeface="Menlo"/>
+              </a:rPr>
+              <a:t> {string} de {string} à {string} le {string}")</a:t>
             </a:r>
           </a:p>
           <a:p>
             <a:pPr algn="l">
               <a:lnSpc>
-                <a:spcPct val="120000"/>
+                <a:spcPct val="110000"/>
               </a:lnSpc>
             </a:pPr>
             <a:r>
-              <a:rPr sz="1350" b="0" i="0">
+              <a:rPr sz="1150" b="0" i="0" dirty="0">
                 <a:solidFill>
                   <a:srgbClr val="E7ECF5"/>
                 </a:solidFill>
                 <a:latin typeface="Menlo"/>
               </a:rPr>
-              <a:t>    public void jai_deja_levenement(String titre, String debut, String fin, String date) {</a:t>
+              <a:t>    public void </a:t>
+            </a:r>
+            <a:r>
+              <a:rPr sz="1150" b="0" i="0" dirty="0" err="1">
+                <a:solidFill>
+                  <a:srgbClr val="E7ECF5"/>
+                </a:solidFill>
+                <a:latin typeface="Menlo"/>
+              </a:rPr>
+              <a:t>jai_deja_levenement</a:t>
+            </a:r>
+            <a:r>
+              <a:rPr sz="1150" b="0" i="0" dirty="0">
+                <a:solidFill>
+                  <a:srgbClr val="E7ECF5"/>
+                </a:solidFill>
+                <a:latin typeface="Menlo"/>
+              </a:rPr>
+              <a:t>(String </a:t>
+            </a:r>
+            <a:r>
+              <a:rPr sz="1150" b="0" i="0" dirty="0" err="1">
+                <a:solidFill>
+                  <a:srgbClr val="E7ECF5"/>
+                </a:solidFill>
+                <a:latin typeface="Menlo"/>
+              </a:rPr>
+              <a:t>titre</a:t>
+            </a:r>
+            <a:r>
+              <a:rPr sz="1150" b="0" i="0" dirty="0">
+                <a:solidFill>
+                  <a:srgbClr val="E7ECF5"/>
+                </a:solidFill>
+                <a:latin typeface="Menlo"/>
+              </a:rPr>
+              <a:t>, String debut, String fin, String date) {</a:t>
             </a:r>
           </a:p>
           <a:p>
             <a:pPr algn="l">
               <a:lnSpc>
-                <a:spcPct val="120000"/>
+                <a:spcPct val="110000"/>
               </a:lnSpc>
             </a:pPr>
             <a:r>
-              <a:rPr sz="1350" b="0" i="0">
+              <a:rPr sz="1150" b="0" i="0" dirty="0">
                 <a:solidFill>
                   <a:srgbClr val="E7ECF5"/>
                 </a:solidFill>
                 <a:latin typeface="Menlo"/>
               </a:rPr>
-              <a:t>        creerEvenement(titre, debut, fin, date);</a:t>
+              <a:t>        </a:t>
+            </a:r>
+            <a:r>
+              <a:rPr sz="1150" b="0" i="0" dirty="0" err="1">
+                <a:solidFill>
+                  <a:srgbClr val="E7ECF5"/>
+                </a:solidFill>
+                <a:latin typeface="Menlo"/>
+              </a:rPr>
+              <a:t>creerEvenement</a:t>
+            </a:r>
+            <a:r>
+              <a:rPr sz="1150" b="0" i="0" dirty="0">
+                <a:solidFill>
+                  <a:srgbClr val="E7ECF5"/>
+                </a:solidFill>
+                <a:latin typeface="Menlo"/>
+              </a:rPr>
+              <a:t>(</a:t>
+            </a:r>
+            <a:r>
+              <a:rPr sz="1150" b="0" i="0" dirty="0" err="1">
+                <a:solidFill>
+                  <a:srgbClr val="E7ECF5"/>
+                </a:solidFill>
+                <a:latin typeface="Menlo"/>
+              </a:rPr>
+              <a:t>titre</a:t>
+            </a:r>
+            <a:r>
+              <a:rPr sz="1150" b="0" i="0" dirty="0">
+                <a:solidFill>
+                  <a:srgbClr val="E7ECF5"/>
+                </a:solidFill>
+                <a:latin typeface="Menlo"/>
+              </a:rPr>
+              <a:t>, debut, fin, date);</a:t>
             </a:r>
           </a:p>
           <a:p>
             <a:pPr algn="l">
               <a:lnSpc>
-                <a:spcPct val="120000"/>
+                <a:spcPct val="110000"/>
               </a:lnSpc>
             </a:pPr>
             <a:r>
-              <a:rPr sz="1350" b="0" i="0">
+              <a:rPr sz="1150" b="0" i="0" dirty="0">
                 <a:solidFill>
                   <a:srgbClr val="E7ECF5"/>
                 </a:solidFill>
@@ -8295,59 +8433,167 @@
           <a:p>
             <a:pPr algn="l">
               <a:lnSpc>
-                <a:spcPct val="120000"/>
+                <a:spcPct val="110000"/>
               </a:lnSpc>
             </a:pPr>
             <a:r>
-              <a:rPr sz="1350" b="0" i="0">
+              <a:rPr sz="1150" b="0" i="0" dirty="0">
                 <a:solidFill>
                   <a:srgbClr val="E7ECF5"/>
                 </a:solidFill>
                 <a:latin typeface="Menlo"/>
               </a:rPr>
-              <a:t>    @When("je crée l'événement {string} de {string} à {string} le {string}")</a:t>
+              <a:t>    @When("je </a:t>
+            </a:r>
+            <a:r>
+              <a:rPr sz="1150" b="0" i="0" dirty="0" err="1">
+                <a:solidFill>
+                  <a:srgbClr val="E7ECF5"/>
+                </a:solidFill>
+                <a:latin typeface="Menlo"/>
+              </a:rPr>
+              <a:t>crée</a:t>
+            </a:r>
+            <a:r>
+              <a:rPr sz="1150" b="0" i="0" dirty="0">
+                <a:solidFill>
+                  <a:srgbClr val="E7ECF5"/>
+                </a:solidFill>
+                <a:latin typeface="Menlo"/>
+              </a:rPr>
+              <a:t> </a:t>
+            </a:r>
+            <a:r>
+              <a:rPr sz="1150" b="0" i="0" dirty="0" err="1">
+                <a:solidFill>
+                  <a:srgbClr val="E7ECF5"/>
+                </a:solidFill>
+                <a:latin typeface="Menlo"/>
+              </a:rPr>
+              <a:t>l'événement</a:t>
+            </a:r>
+            <a:r>
+              <a:rPr sz="1150" b="0" i="0" dirty="0">
+                <a:solidFill>
+                  <a:srgbClr val="E7ECF5"/>
+                </a:solidFill>
+                <a:latin typeface="Menlo"/>
+              </a:rPr>
+              <a:t> {string} de {string} à {string} le {string}")</a:t>
             </a:r>
           </a:p>
           <a:p>
             <a:pPr algn="l">
               <a:lnSpc>
-                <a:spcPct val="120000"/>
+                <a:spcPct val="110000"/>
               </a:lnSpc>
             </a:pPr>
             <a:r>
-              <a:rPr sz="1350" b="0" i="0">
+              <a:rPr sz="1150" b="0" i="0" dirty="0">
                 <a:solidFill>
                   <a:srgbClr val="E7ECF5"/>
                 </a:solidFill>
                 <a:latin typeface="Menlo"/>
               </a:rPr>
-              <a:t>    public void je_cree_levenement(String titre, String debut, String fin, String date) {</a:t>
+              <a:t>    public void </a:t>
+            </a:r>
+            <a:r>
+              <a:rPr sz="1150" b="0" i="0" dirty="0" err="1">
+                <a:solidFill>
+                  <a:srgbClr val="E7ECF5"/>
+                </a:solidFill>
+                <a:latin typeface="Menlo"/>
+              </a:rPr>
+              <a:t>je_cree_levenement</a:t>
+            </a:r>
+            <a:r>
+              <a:rPr sz="1150" b="0" i="0" dirty="0">
+                <a:solidFill>
+                  <a:srgbClr val="E7ECF5"/>
+                </a:solidFill>
+                <a:latin typeface="Menlo"/>
+              </a:rPr>
+              <a:t>(String </a:t>
+            </a:r>
+            <a:r>
+              <a:rPr sz="1150" b="0" i="0" dirty="0" err="1">
+                <a:solidFill>
+                  <a:srgbClr val="E7ECF5"/>
+                </a:solidFill>
+                <a:latin typeface="Menlo"/>
+              </a:rPr>
+              <a:t>titre</a:t>
+            </a:r>
+            <a:r>
+              <a:rPr sz="1150" b="0" i="0" dirty="0">
+                <a:solidFill>
+                  <a:srgbClr val="E7ECF5"/>
+                </a:solidFill>
+                <a:latin typeface="Menlo"/>
+              </a:rPr>
+              <a:t>, String debut, String fin, String date) {</a:t>
             </a:r>
           </a:p>
           <a:p>
             <a:pPr algn="l">
               <a:lnSpc>
-                <a:spcPct val="120000"/>
+                <a:spcPct val="110000"/>
               </a:lnSpc>
             </a:pPr>
             <a:r>
-              <a:rPr sz="1350" b="0" i="0">
+              <a:rPr sz="1150" b="0" i="0" dirty="0">
                 <a:solidFill>
                   <a:srgbClr val="E7ECF5"/>
                 </a:solidFill>
                 <a:latin typeface="Menlo"/>
               </a:rPr>
-              <a:t>        creerEvenement(titre, debut, fin, date);</a:t>
+              <a:t>        </a:t>
+            </a:r>
+            <a:r>
+              <a:rPr sz="1150" b="0" i="0" dirty="0" err="1">
+                <a:solidFill>
+                  <a:srgbClr val="E7ECF5"/>
+                </a:solidFill>
+                <a:latin typeface="Menlo"/>
+              </a:rPr>
+              <a:t>creerEvenement</a:t>
+            </a:r>
+            <a:r>
+              <a:rPr sz="1150" b="0" i="0" dirty="0">
+                <a:solidFill>
+                  <a:srgbClr val="E7ECF5"/>
+                </a:solidFill>
+                <a:latin typeface="Menlo"/>
+              </a:rPr>
+              <a:t>(</a:t>
+            </a:r>
+            <a:r>
+              <a:rPr sz="1150" b="0" i="0" dirty="0" err="1">
+                <a:solidFill>
+                  <a:srgbClr val="E7ECF5"/>
+                </a:solidFill>
+                <a:latin typeface="Menlo"/>
+              </a:rPr>
+              <a:t>titre</a:t>
+            </a:r>
+            <a:r>
+              <a:rPr sz="1150" b="0" i="0" dirty="0">
+                <a:solidFill>
+                  <a:srgbClr val="E7ECF5"/>
+                </a:solidFill>
+                <a:latin typeface="Menlo"/>
+              </a:rPr>
+              <a:t>, debut, fin, date);</a:t>
             </a:r>
           </a:p>
           <a:p>
             <a:pPr algn="l">
               <a:lnSpc>
-                <a:spcPct val="120000"/>
+                <a:spcPct val="110000"/>
               </a:lnSpc>
             </a:pPr>
             <a:r>
-              <a:rPr sz="1350" b="0" i="0">
+              <a:rPr sz="1150" b="0" i="0" dirty="0">
                 <a:solidFill>
                   <a:srgbClr val="E7ECF5"/>
                 </a:solidFill>
@@ -8359,59 +8605,203 @@
           <a:p>
             <a:pPr algn="l">
               <a:lnSpc>
-                <a:spcPct val="120000"/>
+                <a:spcPct val="110000"/>
               </a:lnSpc>
             </a:pPr>
             <a:r>
-              <a:rPr sz="1350" b="0" i="0">
+              <a:rPr sz="1150" b="0" i="0" dirty="0">
                 <a:solidFill>
                   <a:srgbClr val="E7ECF5"/>
                 </a:solidFill>
                 <a:latin typeface="Menlo"/>
               </a:rPr>
-              <a:t>    @Then("la création est refusée pour cause de conflit d'horaire")</a:t>
+              <a:t>    @Then("la </a:t>
+            </a:r>
+            <a:r>
+              <a:rPr sz="1150" b="0" i="0" dirty="0" err="1">
+                <a:solidFill>
+                  <a:srgbClr val="E7ECF5"/>
+                </a:solidFill>
+                <a:latin typeface="Menlo"/>
+              </a:rPr>
+              <a:t>création</a:t>
+            </a:r>
+            <a:r>
+              <a:rPr sz="1150" b="0" i="0" dirty="0">
+                <a:solidFill>
+                  <a:srgbClr val="E7ECF5"/>
+                </a:solidFill>
+                <a:latin typeface="Menlo"/>
+              </a:rPr>
+              <a:t> est </a:t>
+            </a:r>
+            <a:r>
+              <a:rPr sz="1150" b="0" i="0" dirty="0" err="1">
+                <a:solidFill>
+                  <a:srgbClr val="E7ECF5"/>
+                </a:solidFill>
+                <a:latin typeface="Menlo"/>
+              </a:rPr>
+              <a:t>refusée</a:t>
+            </a:r>
+            <a:r>
+              <a:rPr sz="1150" b="0" i="0" dirty="0">
+                <a:solidFill>
+                  <a:srgbClr val="E7ECF5"/>
+                </a:solidFill>
+                <a:latin typeface="Menlo"/>
+              </a:rPr>
+              <a:t> pour cause de </a:t>
+            </a:r>
+            <a:r>
+              <a:rPr sz="1150" b="0" i="0" dirty="0" err="1">
+                <a:solidFill>
+                  <a:srgbClr val="E7ECF5"/>
+                </a:solidFill>
+                <a:latin typeface="Menlo"/>
+              </a:rPr>
+              <a:t>conflit</a:t>
+            </a:r>
+            <a:r>
+              <a:rPr sz="1150" b="0" i="0" dirty="0">
+                <a:solidFill>
+                  <a:srgbClr val="E7ECF5"/>
+                </a:solidFill>
+                <a:latin typeface="Menlo"/>
+              </a:rPr>
+              <a:t> </a:t>
+            </a:r>
+            <a:r>
+              <a:rPr sz="1150" b="0" i="0" dirty="0" err="1">
+                <a:solidFill>
+                  <a:srgbClr val="E7ECF5"/>
+                </a:solidFill>
+                <a:latin typeface="Menlo"/>
+              </a:rPr>
+              <a:t>d'horaire</a:t>
+            </a:r>
+            <a:r>
+              <a:rPr sz="1150" b="0" i="0" dirty="0">
+                <a:solidFill>
+                  <a:srgbClr val="E7ECF5"/>
+                </a:solidFill>
+                <a:latin typeface="Menlo"/>
+              </a:rPr>
+              <a:t>")</a:t>
             </a:r>
           </a:p>
           <a:p>
             <a:pPr algn="l">
               <a:lnSpc>
-                <a:spcPct val="120000"/>
+                <a:spcPct val="110000"/>
               </a:lnSpc>
             </a:pPr>
             <a:r>
-              <a:rPr sz="1350" b="0" i="0">
+              <a:rPr sz="1150" b="0" i="0" dirty="0">
                 <a:solidFill>
                   <a:srgbClr val="E7ECF5"/>
                 </a:solidFill>
                 <a:latin typeface="Menlo"/>
               </a:rPr>
-              <a:t>    public void la_creation_est_refusee_pour_conflit() {</a:t>
+              <a:t>    public void </a:t>
+            </a:r>
+            <a:r>
+              <a:rPr sz="1150" b="0" i="0" dirty="0" err="1">
+                <a:solidFill>
+                  <a:srgbClr val="E7ECF5"/>
+                </a:solidFill>
+                <a:latin typeface="Menlo"/>
+              </a:rPr>
+              <a:t>la_creation_est_refusee_pour_conflit</a:t>
+            </a:r>
+            <a:r>
+              <a:rPr sz="1150" b="0" i="0" dirty="0">
+                <a:solidFill>
+                  <a:srgbClr val="E7ECF5"/>
+                </a:solidFill>
+                <a:latin typeface="Menlo"/>
+              </a:rPr>
+              <a:t>() {</a:t>
             </a:r>
           </a:p>
           <a:p>
             <a:pPr algn="l">
               <a:lnSpc>
-                <a:spcPct val="120000"/>
+                <a:spcPct val="110000"/>
               </a:lnSpc>
             </a:pPr>
             <a:r>
-              <a:rPr sz="1350" b="0" i="0">
+              <a:rPr sz="1150" b="0" i="0" dirty="0">
                 <a:solidFill>
                   <a:srgbClr val="E7ECF5"/>
                 </a:solidFill>
                 <a:latin typeface="Menlo"/>
               </a:rPr>
-              <a:t>        assertThat(lastResponse.statusCode(), equalTo(409));</a:t>
+              <a:t>        </a:t>
+            </a:r>
+            <a:r>
+              <a:rPr sz="1150" b="0" i="0" dirty="0" err="1">
+                <a:solidFill>
+                  <a:srgbClr val="E7ECF5"/>
+                </a:solidFill>
+                <a:latin typeface="Menlo"/>
+              </a:rPr>
+              <a:t>assertThat</a:t>
+            </a:r>
+            <a:r>
+              <a:rPr sz="1150" b="0" i="0" dirty="0">
+                <a:solidFill>
+                  <a:srgbClr val="E7ECF5"/>
+                </a:solidFill>
+                <a:latin typeface="Menlo"/>
+              </a:rPr>
+              <a:t>(</a:t>
+            </a:r>
+            <a:r>
+              <a:rPr sz="1150" b="0" i="0" dirty="0" err="1">
+                <a:solidFill>
+                  <a:srgbClr val="E7ECF5"/>
+                </a:solidFill>
+                <a:latin typeface="Menlo"/>
+              </a:rPr>
+              <a:t>lastResponse.statusCode</a:t>
+            </a:r>
+            <a:r>
+              <a:rPr sz="1150" b="0" i="0" dirty="0">
+                <a:solidFill>
+                  <a:srgbClr val="E7ECF5"/>
+                </a:solidFill>
+                <a:latin typeface="Menlo"/>
+              </a:rPr>
+              <a:t>(), </a:t>
+            </a:r>
+            <a:r>
+              <a:rPr sz="1150" b="0" i="0" dirty="0" err="1">
+                <a:solidFill>
+                  <a:srgbClr val="E7ECF5"/>
+                </a:solidFill>
+                <a:latin typeface="Menlo"/>
+              </a:rPr>
+              <a:t>equalTo</a:t>
+            </a:r>
+            <a:r>
+              <a:rPr sz="1150" b="0" i="0" dirty="0">
+                <a:solidFill>
+                  <a:srgbClr val="E7ECF5"/>
+                </a:solidFill>
+                <a:latin typeface="Menlo"/>
+              </a:rPr>
+              <a:t>(409));</a:t>
             </a:r>
           </a:p>
           <a:p>
             <a:pPr algn="l">
               <a:lnSpc>
-                <a:spcPct val="120000"/>
+                <a:spcPct val="110000"/>
               </a:lnSpc>
             </a:pPr>
             <a:r>
-              <a:rPr sz="1350" b="0" i="0">
+              <a:rPr sz="1150" b="0" i="0" dirty="0">
                 <a:solidFill>
                   <a:srgbClr val="E7ECF5"/>
                 </a:solidFill>
@@ -8423,27 +8813,114 @@
           <a:p>
             <a:pPr algn="l">
               <a:lnSpc>
-                <a:spcPct val="120000"/>
+                <a:spcPct val="110000"/>
               </a:lnSpc>
             </a:pPr>
             <a:r>
-              <a:rPr sz="1350" b="0" i="0">
+              <a:rPr sz="1150" b="0" i="0" dirty="0">
                 <a:solidFill>
                   <a:srgbClr val="E7ECF5"/>
                 </a:solidFill>
                 <a:latin typeface="Menlo"/>
               </a:rPr>
-              <a:t>    // creerEvenement() construit le JSON et POST /api/calendrier/evenements</a:t>
-            </a:r>
+              <a:t>    // </a:t>
+            </a:r>
+            <a:r>
+              <a:rPr sz="1150" b="0" i="0" dirty="0" err="1">
+                <a:solidFill>
+                  <a:srgbClr val="E7ECF5"/>
+                </a:solidFill>
+                <a:latin typeface="Menlo"/>
+              </a:rPr>
+              <a:t>creerEvenement</a:t>
+            </a:r>
+            <a:r>
+              <a:rPr sz="1150" b="0" i="0" dirty="0">
+                <a:solidFill>
+                  <a:srgbClr val="E7ECF5"/>
+                </a:solidFill>
+                <a:latin typeface="Menlo"/>
+              </a:rPr>
+              <a:t>() </a:t>
+            </a:r>
+            <a:r>
+              <a:rPr sz="1150" b="0" i="0" dirty="0" err="1">
+                <a:solidFill>
+                  <a:srgbClr val="E7ECF5"/>
+                </a:solidFill>
+                <a:latin typeface="Menlo"/>
+              </a:rPr>
+              <a:t>construit</a:t>
+            </a:r>
+            <a:r>
+              <a:rPr sz="1150" b="0" i="0" dirty="0">
+                <a:solidFill>
+                  <a:srgbClr val="E7ECF5"/>
+                </a:solidFill>
+                <a:latin typeface="Menlo"/>
+              </a:rPr>
+              <a:t> le JSON et POST /</a:t>
+            </a:r>
+            <a:r>
+              <a:rPr sz="1150" b="0" i="0" dirty="0" err="1">
+                <a:solidFill>
+                  <a:srgbClr val="E7ECF5"/>
+                </a:solidFill>
+                <a:latin typeface="Menlo"/>
+              </a:rPr>
+              <a:t>api</a:t>
+            </a:r>
+            <a:r>
+              <a:rPr sz="1150" b="0" i="0" dirty="0">
+                <a:solidFill>
+                  <a:srgbClr val="E7ECF5"/>
+                </a:solidFill>
+                <a:latin typeface="Menlo"/>
+              </a:rPr>
+              <a:t>/</a:t>
+            </a:r>
+            <a:r>
+              <a:rPr sz="1150" b="0" i="0" dirty="0" err="1">
+                <a:solidFill>
+                  <a:srgbClr val="E7ECF5"/>
+                </a:solidFill>
+                <a:latin typeface="Menlo"/>
+              </a:rPr>
+              <a:t>calendrier</a:t>
+            </a:r>
+            <a:r>
+              <a:rPr sz="1150" b="0" i="0" dirty="0">
+                <a:solidFill>
+                  <a:srgbClr val="E7ECF5"/>
+                </a:solidFill>
+                <a:latin typeface="Menlo"/>
+              </a:rPr>
+              <a:t>/</a:t>
+            </a:r>
+            <a:r>
+              <a:rPr sz="1150" b="0" i="0" dirty="0" err="1">
+                <a:solidFill>
+                  <a:srgbClr val="E7ECF5"/>
+                </a:solidFill>
+                <a:latin typeface="Menlo"/>
+              </a:rPr>
+              <a:t>evenements</a:t>
+            </a:r>
+            <a:endParaRPr sz="1150" b="0" i="0" dirty="0">
+              <a:solidFill>
+                <a:srgbClr val="E7ECF5"/>
+              </a:solidFill>
+              <a:latin typeface="Menlo"/>
+            </a:endParaRPr>
           </a:p>
           <a:p>
             <a:pPr algn="l">
               <a:lnSpc>
-                <a:spcPct val="120000"/>
+                <a:spcPct val="110000"/>
               </a:lnSpc>
             </a:pPr>
             <a:r>
-              <a:rPr sz="1350" b="0" i="0">
+              <a:rPr sz="1150" b="0" i="0" dirty="0">
                 <a:solidFill>
                   <a:srgbClr val="E7ECF5"/>
                 </a:solidFill>
@@ -8462,8 +8939,8 @@
         </p:nvSpPr>
         <p:spPr>
           <a:xfrm>
-            <a:off x="822960" y="5989320"/>
-            <a:ext cx="9875520" cy="457200"/>
+            <a:off x="822960" y="5863760"/>
+            <a:ext cx="9759547" cy="474232"/>
           </a:xfrm>
           <a:prstGeom prst="rect">
             <a:avLst/>
@@ -8471,7 +8948,7 @@
           <a:noFill/>
         </p:spPr>
         <p:txBody>
-          <a:bodyPr wrap="square" lIns="0" rIns="0" tIns="0" bIns="0">
+          <a:bodyPr wrap="square" lIns="0" tIns="0" rIns="0" bIns="0">
             <a:spAutoFit/>
           </a:bodyPr>
           <a:lstStyle/>
@@ -8482,13 +8959,121 @@
               </a:lnSpc>
             </a:pPr>
             <a:r>
-              <a:rPr sz="1300" b="0" i="0">
+              <a:rPr sz="1300" b="0" i="0" dirty="0">
                 <a:solidFill>
                   <a:srgbClr val="181D2B"/>
                 </a:solidFill>
                 <a:latin typeface="Helvetica Neue"/>
               </a:rPr>
-              <a:t>@Given / @When / @Then : une expression régulière relie chaque phrase à sa méthode.</a:t>
+              <a:t>@Given / @When / @Then : </a:t>
+            </a:r>
+            <a:r>
+              <a:rPr sz="1300" b="0" i="0" dirty="0" err="1">
+                <a:solidFill>
+                  <a:srgbClr val="181D2B"/>
+                </a:solidFill>
+                <a:latin typeface="Helvetica Neue"/>
+              </a:rPr>
+              <a:t>une</a:t>
+            </a:r>
+            <a:r>
+              <a:rPr sz="1300" b="0" i="0" dirty="0">
+                <a:solidFill>
+                  <a:srgbClr val="181D2B"/>
+                </a:solidFill>
+                <a:latin typeface="Helvetica Neue"/>
+              </a:rPr>
+              <a:t> expression </a:t>
+            </a:r>
+            <a:r>
+              <a:rPr sz="1300" b="0" i="0" dirty="0" err="1">
+                <a:solidFill>
+                  <a:srgbClr val="181D2B"/>
+                </a:solidFill>
+                <a:latin typeface="Helvetica Neue"/>
+              </a:rPr>
+              <a:t>régulière</a:t>
+            </a:r>
+            <a:r>
+              <a:rPr sz="1300" b="0" i="0" dirty="0">
+                <a:solidFill>
+                  <a:srgbClr val="181D2B"/>
+                </a:solidFill>
+                <a:latin typeface="Helvetica Neue"/>
+              </a:rPr>
+              <a:t> </a:t>
+            </a:r>
+            <a:r>
+              <a:rPr sz="1300" b="0" i="0" dirty="0" err="1">
+                <a:solidFill>
+                  <a:srgbClr val="181D2B"/>
+                </a:solidFill>
+                <a:latin typeface="Helvetica Neue"/>
+              </a:rPr>
+              <a:t>relie</a:t>
+            </a:r>
+            <a:r>
+              <a:rPr sz="1300" b="0" i="0" dirty="0">
+                <a:solidFill>
+                  <a:srgbClr val="181D2B"/>
+                </a:solidFill>
+                <a:latin typeface="Helvetica Neue"/>
+              </a:rPr>
+              <a:t> </a:t>
+            </a:r>
+            <a:r>
+              <a:rPr sz="1300" b="0" i="0" dirty="0" err="1">
+                <a:solidFill>
+                  <a:srgbClr val="181D2B"/>
+                </a:solidFill>
+                <a:latin typeface="Helvetica Neue"/>
+              </a:rPr>
+              <a:t>chaque</a:t>
+            </a:r>
+            <a:r>
+              <a:rPr sz="1300" b="0" i="0" dirty="0">
+                <a:solidFill>
+                  <a:srgbClr val="181D2B"/>
+                </a:solidFill>
+                <a:latin typeface="Helvetica Neue"/>
+              </a:rPr>
+              <a:t> phrase à </a:t>
+            </a:r>
+            <a:r>
+              <a:rPr sz="1300" b="0" i="0" dirty="0" err="1">
+                <a:solidFill>
+                  <a:srgbClr val="181D2B"/>
+                </a:solidFill>
+                <a:latin typeface="Helvetica Neue"/>
+              </a:rPr>
+              <a:t>sa</a:t>
+            </a:r>
+            <a:r>
+              <a:rPr sz="1300" b="0" i="0" dirty="0">
+                <a:solidFill>
+                  <a:srgbClr val="181D2B"/>
+                </a:solidFill>
+                <a:latin typeface="Helvetica Neue"/>
+              </a:rPr>
+              <a:t> </a:t>
+            </a:r>
+            <a:r>
+              <a:rPr sz="1300" b="0" i="0" dirty="0" err="1">
+                <a:solidFill>
+                  <a:srgbClr val="181D2B"/>
+                </a:solidFill>
+                <a:latin typeface="Helvetica Neue"/>
+              </a:rPr>
+              <a:t>méthode</a:t>
+            </a:r>
+            <a:r>
+              <a:rPr sz="1300" b="0" i="0" dirty="0">
+                <a:solidFill>
+                  <a:srgbClr val="181D2B"/>
+                </a:solidFill>
+                <a:latin typeface="Helvetica Neue"/>
+              </a:rPr>
+              <a:t>.</a:t>
             </a:r>
           </a:p>
           <a:p>
@@ -8498,13 +9083,58 @@
               </a:lnSpc>
             </a:pPr>
             <a:r>
-              <a:rPr sz="1300" b="0" i="0">
+              <a:rPr sz="1300" b="0" i="0" dirty="0" err="1">
                 <a:solidFill>
                   <a:srgbClr val="181D2B"/>
                 </a:solidFill>
                 <a:latin typeface="Helvetica Neue"/>
               </a:rPr>
-              <a:t>Même fichier pour les trois : EventStepDefinitions.java.</a:t>
+              <a:t>Même</a:t>
+            </a:r>
+            <a:r>
+              <a:rPr sz="1300" b="0" i="0" dirty="0">
+                <a:solidFill>
+                  <a:srgbClr val="181D2B"/>
+                </a:solidFill>
+                <a:latin typeface="Helvetica Neue"/>
+              </a:rPr>
+              <a:t> </a:t>
+            </a:r>
+            <a:r>
+              <a:rPr sz="1300" b="0" i="0" dirty="0" err="1">
+                <a:solidFill>
+                  <a:srgbClr val="181D2B"/>
+                </a:solidFill>
+                <a:latin typeface="Helvetica Neue"/>
+              </a:rPr>
+              <a:t>fichier</a:t>
+            </a:r>
+            <a:r>
+              <a:rPr sz="1300" b="0" i="0" dirty="0">
+                <a:solidFill>
+                  <a:srgbClr val="181D2B"/>
+                </a:solidFill>
+                <a:latin typeface="Helvetica Neue"/>
+              </a:rPr>
+              <a:t> pour les trois : </a:t>
+            </a:r>
+            <a:r>
+              <a:rPr sz="1300" b="0" i="0" dirty="0" err="1">
+                <a:solidFill>
+                  <a:srgbClr val="181D2B"/>
+                </a:solidFill>
+                <a:latin typeface="Helvetica Neue"/>
+              </a:rPr>
+              <a:t>EventStepDefinitions.java</a:t>
+            </a:r>
+            <a:r>
+              <a:rPr sz="1300" b="0" i="0" dirty="0">
+                <a:solidFill>
+                  <a:srgbClr val="181D2B"/>
+                </a:solidFill>
+                <a:latin typeface="Helvetica Neue"/>
+              </a:rPr>
+              <a:t>.</a:t>
             </a:r>
           </a:p>
         </p:txBody>
@@ -8579,7 +9209,7 @@
           <a:noFill/>
         </p:spPr>
         <p:txBody>
-          <a:bodyPr wrap="square" lIns="0" rIns="0" tIns="0" bIns="0">
+          <a:bodyPr wrap="square" lIns="0" tIns="0" rIns="0" bIns="0">
             <a:spAutoFit/>
           </a:bodyPr>
           <a:lstStyle/>
@@ -8603,12 +9233,12 @@
       </p:sp>
     </p:spTree>
   </p:cSld>
-  <p:transition spd="fast">
-    <p:fade/>
-  </p:transition>
   <p:clrMapOvr>
     <a:masterClrMapping/>
   </p:clrMapOvr>
+  <p:transition>
+    <p:fade/>
+  </p:transition>
 </p:sld>
 </file>
 

</xml_diff>